<commit_message>
Refactor EDA notebook and remove unused presentation files
- Updated the EDA notebook (01_eda.ipynb) to clarify the dataset's structure and quality, removing unnecessary line breaks for better readability.
- Deleted obsolete PowerPoint files related to the Lending Club project to clean up the repository.
</commit_message>
<xml_diff>
--- a/project 1/LendingClub_Project1.pptx
+++ b/project 1/LendingClub_Project1.pptx
@@ -3700,7 +3700,7 @@
               <a:buChar char="•"/>
             </a:pPr>
             <a:r>
-              <a:rPr lang="en-US" sz="1600">
+              <a:rPr lang="en-US" sz="1600" dirty="0">
                 <a:solidFill>
                   <a:srgbClr val="1A1A1E"/>
                 </a:solidFill>
@@ -3710,7 +3710,7 @@
               </a:rPr>
               <a:t>Predict interest rate (loan APR, %) for 10,000 held-out applications and minimize test-set RMSE.</a:t>
             </a:r>
-            <a:endParaRPr lang="en-US" sz="1600">
+            <a:endParaRPr lang="en-US" sz="1600" dirty="0">
               <a:latin typeface="Calibri"/>
               <a:ea typeface="Calibri"/>
               <a:cs typeface="Calibri"/>
@@ -3728,7 +3728,7 @@
               <a:buChar char="•"/>
             </a:pPr>
             <a:r>
-              <a:rPr lang="en-US" sz="1600">
+              <a:rPr lang="en-US" sz="1600" dirty="0">
                 <a:solidFill>
                   <a:srgbClr val="1A1A1E"/>
                 </a:solidFill>
@@ -3738,7 +3738,7 @@
               </a:rPr>
               <a:t>Target ranges 6.46–30.99%, mean 12.95, right-skewed (skew 0.85).</a:t>
             </a:r>
-            <a:endParaRPr lang="en-US" sz="1600"/>
+            <a:endParaRPr lang="en-US" sz="1600" dirty="0"/>
           </a:p>
           <a:p>
             <a:pPr marL="177800" indent="-177800">
@@ -3752,7 +3752,7 @@
               <a:buChar char="•"/>
             </a:pPr>
             <a:r>
-              <a:rPr lang="en-US" sz="1600">
+              <a:rPr lang="en-US" sz="1600" dirty="0">
                 <a:solidFill>
                   <a:srgbClr val="1A1A1E"/>
                 </a:solidFill>
@@ -3762,7 +3762,7 @@
               </a:rPr>
               <a:t>Pure regression on tabular application data — no time series, no text scoring.</a:t>
             </a:r>
-            <a:endParaRPr lang="en-US" sz="1600"/>
+            <a:endParaRPr lang="en-US" sz="1600" dirty="0"/>
           </a:p>
         </p:txBody>
       </p:sp>
@@ -3841,7 +3841,7 @@
               <a:buChar char="•"/>
             </a:pPr>
             <a:r>
-              <a:rPr lang="en-US" sz="1600">
+              <a:rPr lang="en-US" sz="1600" dirty="0">
                 <a:solidFill>
                   <a:srgbClr val="1A1A1E"/>
                 </a:solidFill>
@@ -3851,7 +3851,7 @@
               </a:rPr>
               <a:t>Loan status is post-origination leakage and is dropped before any modeling.</a:t>
             </a:r>
-            <a:endParaRPr lang="en-US" sz="1600">
+            <a:endParaRPr lang="en-US" sz="1600" dirty="0">
               <a:latin typeface="Calibri"/>
               <a:ea typeface="Calibri"/>
               <a:cs typeface="Calibri"/>
@@ -3869,7 +3869,7 @@
               <a:buChar char="•"/>
             </a:pPr>
             <a:r>
-              <a:rPr lang="en-US" sz="1600">
+              <a:rPr lang="en-US" sz="1600" dirty="0">
                 <a:solidFill>
                   <a:srgbClr val="1A1A1E"/>
                 </a:solidFill>
@@ -3879,7 +3879,7 @@
               </a:rPr>
               <a:t>Grade / sub-grade / installment are absent from this slice — no shortcut to APR.</a:t>
             </a:r>
-            <a:endParaRPr lang="en-US" sz="1600">
+            <a:endParaRPr lang="en-US" sz="1600" dirty="0">
               <a:latin typeface="Calibri"/>
               <a:ea typeface="Calibri"/>
               <a:cs typeface="Calibri"/>
@@ -3897,7 +3897,7 @@
               <a:buChar char="•"/>
             </a:pPr>
             <a:r>
-              <a:rPr lang="en-US" sz="1600">
+              <a:rPr lang="en-US" sz="1600" dirty="0">
                 <a:solidFill>
                   <a:srgbClr val="1A1A1E"/>
                 </a:solidFill>
@@ -3907,7 +3907,7 @@
               </a:rPr>
               <a:t>No date columns exist, so validation uses a random 80/20 split, not a temporal one.</a:t>
             </a:r>
-            <a:endParaRPr lang="en-US" sz="1600"/>
+            <a:endParaRPr lang="en-US" sz="1600" dirty="0"/>
           </a:p>
         </p:txBody>
       </p:sp>

</xml_diff>